<commit_message>
feat: M3 kpi-row-chart chart data-swap via pptx-automizer
Swap fill-plan datasets into the pre-authored stacked-bar at slot.chart
using modify.setChartData, with chart round-trip integration tests and
placeholder master labels aligned to the valid fixture.

Co-authored-by: Cursor <cursoragent@cursor.com>
</commit_message>
<xml_diff>
--- a/templates/PLACEHOLDER-report.master.pptx
+++ b/templates/PLACEHOLDER-report.master.pptx
@@ -180,7 +180,7 @@
                     <c:v>Industry C</c:v>
                   </c:pt>
                   <c:pt idx="3">
-                    <c:v>Ammonia</c:v>
+                    <c:v>Ammonia (baseline)</c:v>
                   </c:pt>
                 </c:lvl>
               </c:multiLvlStrCache>
@@ -269,7 +269,7 @@
                     <c:v>Industry C</c:v>
                   </c:pt>
                   <c:pt idx="3">
-                    <c:v>Ammonia</c:v>
+                    <c:v>Ammonia (baseline)</c:v>
                   </c:pt>
                 </c:lvl>
               </c:multiLvlStrCache>
@@ -358,7 +358,7 @@
                     <c:v>Industry C</c:v>
                   </c:pt>
                   <c:pt idx="3">
-                    <c:v>Ammonia</c:v>
+                    <c:v>Ammonia (baseline)</c:v>
                   </c:pt>
                 </c:lvl>
               </c:multiLvlStrCache>

</xml_diff>

<commit_message>
feat: M3 kpi-row-chart chart data-swap via pptx-automizer (#11)
Swap fill-plan datasets into the pre-authored stacked-bar at slot.chart
using modify.setChartData, with chart round-trip integration tests and
placeholder master labels aligned to the valid fixture.

Co-authored-by: Cursor <cursoragent@cursor.com>
</commit_message>
<xml_diff>
--- a/templates/PLACEHOLDER-report.master.pptx
+++ b/templates/PLACEHOLDER-report.master.pptx
@@ -180,7 +180,7 @@
                     <c:v>Industry C</c:v>
                   </c:pt>
                   <c:pt idx="3">
-                    <c:v>Ammonia</c:v>
+                    <c:v>Ammonia (baseline)</c:v>
                   </c:pt>
                 </c:lvl>
               </c:multiLvlStrCache>
@@ -269,7 +269,7 @@
                     <c:v>Industry C</c:v>
                   </c:pt>
                   <c:pt idx="3">
-                    <c:v>Ammonia</c:v>
+                    <c:v>Ammonia (baseline)</c:v>
                   </c:pt>
                 </c:lvl>
               </c:multiLvlStrCache>
@@ -358,7 +358,7 @@
                     <c:v>Industry C</c:v>
                   </c:pt>
                   <c:pt idx="3">
-                    <c:v>Ammonia</c:v>
+                    <c:v>Ammonia (baseline)</c:v>
                   </c:pt>
                 </c:lvl>
               </c:multiLvlStrCache>

</xml_diff>